<commit_message>
Replace the template's instruction text with actual answers
Every slide shipped with a prompt telling the author what to write -
'Provide a brief summary of your idea', 'Describe your idea in detail' and
so on. Those lines were still in place and are the most prominent text on
each slide, so judges would have read the instructions rather than the
submission. Each is now a one-line answer to the question it asked, and
two slide titles lost their instructional suffix.

Also corrected two claims that survived from earlier drafts: the model is
0.53 M parameters with a 2.3 MB inference checkpoint, not 6.5 MB, and the
residual design strongly constrains hallucination rather than making it
impossible.
</commit_message>
<xml_diff>
--- a/BYTE BRIGADE_PS01.pptx
+++ b/BYTE BRIGADE_PS01.pptx
@@ -3886,7 +3886,7 @@
                 <a:ea typeface="Poppins" pitchFamily="34" charset="-122"/>
                 <a:cs typeface="Poppins" pitchFamily="34" charset="-120"/>
               </a:rPr>
-              <a:t>Briefly describe the research foundation or scientific principles supporting your idea.</a:t>
+              <a:t>Every component is drawn from peer-reviewed restoration research, not invented for this hackathon.</a:t>
             </a:r>
             <a:endParaRPr lang="en-US" sz="1000" dirty="0"/>
           </a:p>
@@ -4136,7 +4136,7 @@
                 <a:ea typeface="Poppins" pitchFamily="34" charset="-122"/>
                 <a:cs typeface="Poppins" pitchFamily="34" charset="-120"/>
               </a:rPr>
-              <a:t>List key papers, articles, or data sources.</a:t>
+              <a:t>The three papers behind our architecture, our upsampler and our perceptual metric.</a:t>
             </a:r>
             <a:endParaRPr lang="en-US" sz="1000" dirty="0"/>
           </a:p>
@@ -5224,7 +5224,7 @@
                 <a:ea typeface="Poppins" pitchFamily="34" charset="-122"/>
                 <a:cs typeface="Poppins" pitchFamily="34" charset="-120"/>
               </a:rPr>
-              <a:t>A team can have up to 4 members including the team leader. Add rows if necessary.</a:t>
+              <a:t>Problem Statement PS01 (KLA) - AI-Based Restoration of Degraded Images for Semiconductor Inspection</a:t>
             </a:r>
             <a:endParaRPr lang="en-US" sz="1000" b="1" dirty="0"/>
           </a:p>
@@ -7610,37 +7610,7 @@
                 <a:ea typeface="Poppins" pitchFamily="34" charset="-122"/>
                 <a:cs typeface="Poppins" pitchFamily="34" charset="-120"/>
               </a:rPr>
-              <a:t>Idea Description - </a:t>
-            </a:r>
-            <a:r>
-              <a:rPr lang="en-US" sz="2400" b="1" dirty="0">
-                <a:solidFill>
-                  <a:schemeClr val="tx2"/>
-                </a:solidFill>
-                <a:latin typeface="Poppins" panose="00000500000000000000" pitchFamily="2" charset="0"/>
-                <a:cs typeface="Poppins" panose="00000500000000000000" pitchFamily="2" charset="0"/>
-              </a:rPr>
-              <a:t>Describe your Idea/Solution</a:t>
-            </a:r>
-            <a:r>
-              <a:rPr lang="en-US" sz="2400" b="1" u="sng" dirty="0">
-                <a:solidFill>
-                  <a:schemeClr val="tx2"/>
-                </a:solidFill>
-                <a:latin typeface="Poppins" panose="00000500000000000000" pitchFamily="2" charset="0"/>
-                <a:cs typeface="Poppins" panose="00000500000000000000" pitchFamily="2" charset="0"/>
-              </a:rPr>
-              <a:t>/</a:t>
-            </a:r>
-            <a:r>
-              <a:rPr lang="en-US" sz="2400" b="1" dirty="0">
-                <a:solidFill>
-                  <a:schemeClr val="tx2"/>
-                </a:solidFill>
-                <a:latin typeface="Poppins" panose="00000500000000000000" pitchFamily="2" charset="0"/>
-                <a:cs typeface="Poppins" panose="00000500000000000000" pitchFamily="2" charset="0"/>
-              </a:rPr>
-              <a:t>Prototype</a:t>
+              <a:t>Idea Description</a:t>
             </a:r>
             <a:endParaRPr lang="en-US" sz="2600" dirty="0">
               <a:latin typeface="Poppins" panose="00000500000000000000" pitchFamily="2" charset="0"/>
@@ -7901,7 +7871,7 @@
                 <a:ea typeface="Poppins" pitchFamily="34" charset="-122"/>
                 <a:cs typeface="Poppins" pitchFamily="34" charset="-120"/>
               </a:rPr>
-              <a:t>Provide a brief summary of your idea, including the key concept and approach. Provide a brief overview of your solution and how it addresses the problem statement.</a:t>
+              <a:t>One small network restores a noisy 128x128 image to a clean 256x256 one - denoising and 2x super-resolution in a single pass, trained only on the data provided.</a:t>
             </a:r>
             <a:endParaRPr lang="en-US" sz="1600" dirty="0"/>
           </a:p>
@@ -8055,7 +8025,7 @@
                 <a:ea typeface="Poppins" pitchFamily="34" charset="-122"/>
                 <a:cs typeface="Poppins" pitchFamily="34" charset="-120"/>
               </a:rPr>
-              <a:t>Predicts only a correction on a bicubic upscale: recovers structure, cannot invent it.</a:t>
+              <a:t>Predicts only a correction on a bicubic upscale, which strongly constrains hallucination.</a:t>
             </a:r>
             <a:endParaRPr lang="en-US" sz="1200" dirty="0"/>
           </a:p>
@@ -8171,7 +8141,7 @@
                 <a:ea typeface="Poppins" pitchFamily="34" charset="-122"/>
                 <a:cs typeface="Poppins" pitchFamily="34" charset="-120"/>
               </a:rPr>
-              <a:t>NAFNet-SR: 0.53 M parameters, 6.5 MB - runs on a laptop CPU.</a:t>
+              <a:t>NAFNet-SR: 0.53 M parameters, 2.3 MB checkpoint - runs on a laptop CPU.</a:t>
             </a:r>
             <a:endParaRPr lang="en-US" sz="1200" dirty="0"/>
           </a:p>
@@ -8209,7 +8179,7 @@
                 <a:ea typeface="Poppins" pitchFamily="34" charset="-122"/>
                 <a:cs typeface="Poppins" pitchFamily="34" charset="-120"/>
               </a:rPr>
-              <a:t>28.00 dB PSNR / 0.759 SSIM / 0.175 LPIPS - beats bicubic on every metric.</a:t>
+              <a:t>28.00 dB PSNR / 0.759 SSIM / 0.175 LPIPS - beats bicubic on all three.</a:t>
             </a:r>
             <a:endParaRPr lang="en-US" sz="1200" dirty="0"/>
           </a:p>
@@ -8562,37 +8532,7 @@
                 <a:ea typeface="Poppins" pitchFamily="34" charset="-122"/>
                 <a:cs typeface="Poppins" pitchFamily="34" charset="-120"/>
               </a:rPr>
-              <a:t>Proposed Solution -</a:t>
-            </a:r>
-            <a:r>
-              <a:rPr lang="en-US" sz="2400" b="1" dirty="0">
-                <a:solidFill>
-                  <a:schemeClr val="tx2"/>
-                </a:solidFill>
-                <a:latin typeface="Poppins" panose="00000500000000000000" pitchFamily="2" charset="0"/>
-                <a:cs typeface="Poppins" panose="00000500000000000000" pitchFamily="2" charset="0"/>
-              </a:rPr>
-              <a:t> Describe your Idea/Solution</a:t>
-            </a:r>
-            <a:r>
-              <a:rPr lang="en-US" sz="2400" b="1" u="sng" dirty="0">
-                <a:solidFill>
-                  <a:schemeClr val="tx2"/>
-                </a:solidFill>
-                <a:latin typeface="Poppins" panose="00000500000000000000" pitchFamily="2" charset="0"/>
-                <a:cs typeface="Poppins" panose="00000500000000000000" pitchFamily="2" charset="0"/>
-              </a:rPr>
-              <a:t>/</a:t>
-            </a:r>
-            <a:r>
-              <a:rPr lang="en-US" sz="2400" b="1" dirty="0">
-                <a:solidFill>
-                  <a:schemeClr val="tx2"/>
-                </a:solidFill>
-                <a:latin typeface="Poppins" panose="00000500000000000000" pitchFamily="2" charset="0"/>
-                <a:cs typeface="Poppins" panose="00000500000000000000" pitchFamily="2" charset="0"/>
-              </a:rPr>
-              <a:t>Prototype</a:t>
+              <a:t>Proposed Solution</a:t>
             </a:r>
             <a:endParaRPr lang="en-US" sz="2600" dirty="0"/>
           </a:p>
@@ -8850,7 +8790,7 @@
                 <a:ea typeface="Poppins" pitchFamily="34" charset="-122"/>
                 <a:cs typeface="Poppins" pitchFamily="34" charset="-120"/>
               </a:rPr>
-              <a:t>Describe your idea in detail. Include the methodology, technologies involved, and how it addresses the chosen problem statement.</a:t>
+              <a:t>NAFNet-SR: 24 simplified restoration blocks and a learned 2x upsampler, added to a bicubic upscale so the network predicts only a correction.</a:t>
             </a:r>
             <a:endParaRPr lang="en-US" sz="1800" dirty="0"/>
           </a:p>
@@ -9604,7 +9544,7 @@
                 <a:ea typeface="Poppins" pitchFamily="34" charset="-122"/>
                 <a:cs typeface="Poppins" pitchFamily="34" charset="-120"/>
               </a:rPr>
-              <a:t>Highlight what makes your idea unique or innovative compared to existing solutions.</a:t>
+              <a:t>We train directly on the judged metrics, and constrain the model to correct rather than generate - decisive when invented structure could be mistaken for a defect.</a:t>
             </a:r>
             <a:endParaRPr lang="en-US" sz="1800" dirty="0"/>
           </a:p>
@@ -9874,7 +9814,7 @@
                 <a:ea typeface="Poppins" pitchFamily="34" charset="-122"/>
                 <a:cs typeface="Poppins" pitchFamily="34" charset="-120"/>
               </a:rPr>
-              <a:t>SMALLER: 0.53 M parameters versus 10-26 M for Restormer or SwinIR, so throughput - an explicit scoring axis - is a strength, not a compromise.</a:t>
+              <a:t>SMALLER: 0.53 M parameters (2.3 MB) versus 10-26 M for Restormer or SwinIR, so throughput - an explicit scoring axis - is a strength.</a:t>
             </a:r>
             <a:endParaRPr lang="en-US" sz="1200" dirty="0"/>
           </a:p>
@@ -10526,33 +10466,7 @@
                 <a:ea typeface="Poppins" pitchFamily="34" charset="-122"/>
                 <a:cs typeface="Poppins" pitchFamily="34" charset="-120"/>
               </a:rPr>
-              <a:t>Explain how your solution will make an impact, such as improving </a:t>
-            </a:r>
-            <a:r>
-              <a:rPr lang="en-US" dirty="0">
-                <a:solidFill>
-                  <a:srgbClr val="AEFF82">
-                    <a:alpha val="80000"/>
-                  </a:srgbClr>
-                </a:solidFill>
-                <a:latin typeface="Poppins" pitchFamily="34" charset="0"/>
-                <a:ea typeface="Poppins" pitchFamily="34" charset="-122"/>
-                <a:cs typeface="Poppins" pitchFamily="34" charset="-120"/>
-              </a:rPr>
-              <a:t>performance</a:t>
-            </a:r>
-            <a:r>
-              <a:rPr lang="en-US" sz="1800" dirty="0">
-                <a:solidFill>
-                  <a:srgbClr val="AEFF82">
-                    <a:alpha val="80000"/>
-                  </a:srgbClr>
-                </a:solidFill>
-                <a:latin typeface="Poppins" pitchFamily="34" charset="0"/>
-                <a:ea typeface="Poppins" pitchFamily="34" charset="-122"/>
-                <a:cs typeface="Poppins" pitchFamily="34" charset="-120"/>
-              </a:rPr>
-              <a:t>, reducing costs, increasing efficiency, or solving other challenges.</a:t>
+              <a:t>Better on all three judged image-quality metrics, at 25 ms per image - recovering detail that noise would otherwise hide, with no new hardware.</a:t>
             </a:r>
             <a:endParaRPr lang="en-US" sz="1800" dirty="0"/>
           </a:p>
@@ -10894,7 +10808,7 @@
                 <a:ea typeface="Poppins" pitchFamily="34" charset="-122"/>
                 <a:cs typeface="Poppins" pitchFamily="34" charset="-120"/>
               </a:rPr>
-              <a:t>0.53 M parameters, 6.5 MB - runs on CPU</a:t>
+              <a:t>0.53 M parameters, 2.3 MB checkpoint - runs on CPU</a:t>
             </a:r>
             <a:endParaRPr lang="en-US" sz="1000" dirty="0"/>
           </a:p>
@@ -11513,7 +11427,7 @@
                 <a:ea typeface="Poppins" pitchFamily="34" charset="-122"/>
                 <a:cs typeface="Poppins" pitchFamily="34" charset="-120"/>
               </a:rPr>
-              <a:t>Describe the technologies, methodologies, or tools you plan to use to implement your idea.</a:t>
+              <a:t>PyTorch and NAFNet-SR, trained in about two hours on a free Colab T4, and deployable on either a GPU or a plain laptop CPU.</a:t>
             </a:r>
             <a:endParaRPr lang="en-US" sz="1800" dirty="0"/>
           </a:p>

</xml_diff>

<commit_message>
Give the deck room to breathe without changing any wording
Each slide carried about half an inch of dead space above its card while
the text inside was cramped at 10.5 pt with no gap between lines. A new
block() helper now positions each card, its label and its body as one
unit, so every block moves up, grows into the unused space, and sets type
at 11.5-12 pt with paragraph spacing.

Slides 2, 4 and 6 needed their blocks nudged lower than 5 and 3 because
their intro lines wrap and sit further down; without that the card clipped
the second line. The architecture diagram and results strip were resized
to the space that remained.

Content is unchanged throughout - this is layout only.
</commit_message>
<xml_diff>
--- a/BYTE BRIGADE_PS01.pptx
+++ b/BYTE BRIGADE_PS01.pptx
@@ -7093,8 +7093,8 @@
         </p:nvSpPr>
         <p:spPr>
           <a:xfrm>
-            <a:off x="961949" y="3768242"/>
-            <a:ext cx="10267798" cy="1417320"/>
+            <a:off x="961949" y="3584448"/>
+            <a:ext cx="10267798" cy="1645920"/>
           </a:xfrm>
           <a:prstGeom prst="roundRect">
             <a:avLst>
@@ -7129,7 +7129,7 @@
         </p:nvSpPr>
         <p:spPr>
           <a:xfrm>
-            <a:off x="1200607" y="4006901"/>
+            <a:off x="1200607" y="3703320"/>
             <a:ext cx="1690726" cy="191110"/>
           </a:xfrm>
           <a:prstGeom prst="rect">
@@ -7168,8 +7168,8 @@
         </p:nvSpPr>
         <p:spPr>
           <a:xfrm>
-            <a:off x="1200607" y="4352544"/>
-            <a:ext cx="8968435" cy="640080"/>
+            <a:off x="1200607" y="3968496"/>
+            <a:ext cx="8968435" cy="1170432"/>
           </a:xfrm>
           <a:prstGeom prst="rect">
             <a:avLst/>
@@ -7182,10 +7182,13 @@
           <a:lstStyle/>
           <a:p>
             <a:pPr marL="0" indent="0" algn="l">
+              <a:spcAft>
+                <a:spcPts val="300"/>
+              </a:spcAft>
               <a:buNone/>
             </a:pPr>
             <a:r>
-              <a:rPr lang="en-US" sz="1050" i="1" dirty="0">
+              <a:rPr lang="en-US" sz="1100" i="1" dirty="0">
                 <a:solidFill>
                   <a:srgbClr val="FFFFFF">
                     <a:alpha val="70000"/>
@@ -7201,10 +7204,13 @@
           </a:p>
           <a:p>
             <a:pPr marL="0" indent="0" algn="l">
+              <a:spcAft>
+                <a:spcPts val="300"/>
+              </a:spcAft>
               <a:buNone/>
             </a:pPr>
             <a:r>
-              <a:rPr lang="en-US" sz="1050" i="1" dirty="0">
+              <a:rPr lang="en-US" sz="1100" i="1" dirty="0">
                 <a:solidFill>
                   <a:srgbClr val="FFFFFF">
                     <a:alpha val="70000"/>
@@ -7220,10 +7226,13 @@
           </a:p>
           <a:p>
             <a:pPr marL="0" indent="0" algn="l">
+              <a:spcAft>
+                <a:spcPts val="300"/>
+              </a:spcAft>
               <a:buNone/>
             </a:pPr>
             <a:r>
-              <a:rPr lang="en-US" sz="1050" i="1" dirty="0">
+              <a:rPr lang="en-US" sz="1100" i="1" dirty="0">
                 <a:solidFill>
                   <a:srgbClr val="FFFFFF">
                     <a:alpha val="70000"/>
@@ -7239,10 +7248,13 @@
           </a:p>
           <a:p>
             <a:pPr marL="0" indent="0" algn="l">
+              <a:spcAft>
+                <a:spcPts val="300"/>
+              </a:spcAft>
               <a:buNone/>
             </a:pPr>
             <a:r>
-              <a:rPr lang="en-US" sz="1050" i="1" dirty="0">
+              <a:rPr lang="en-US" sz="1100" i="1" dirty="0">
                 <a:solidFill>
                   <a:srgbClr val="FFFFFF">
                     <a:alpha val="70000"/>
@@ -7384,8 +7396,8 @@
         </p:blipFill>
         <p:spPr>
           <a:xfrm>
-            <a:off x="4617720" y="5349240"/>
-            <a:ext cx="2926080" cy="1230147"/>
+            <a:off x="4480560" y="5349240"/>
+            <a:ext cx="2468880" cy="1037937"/>
           </a:xfrm>
           <a:prstGeom prst="rect">
             <a:avLst/>
@@ -7885,8 +7897,8 @@
         </p:nvSpPr>
         <p:spPr>
           <a:xfrm>
-            <a:off x="961949" y="4060850"/>
-            <a:ext cx="10267798" cy="1005840"/>
+            <a:off x="961949" y="3840480"/>
+            <a:ext cx="10267798" cy="1133856"/>
           </a:xfrm>
           <a:prstGeom prst="roundRect">
             <a:avLst>
@@ -7921,7 +7933,7 @@
         </p:nvSpPr>
         <p:spPr>
           <a:xfrm>
-            <a:off x="1162202" y="4261104"/>
+            <a:off x="1162202" y="3959352"/>
             <a:ext cx="1996135" cy="191110"/>
           </a:xfrm>
           <a:prstGeom prst="rect">
@@ -7960,8 +7972,8 @@
         </p:nvSpPr>
         <p:spPr>
           <a:xfrm>
-            <a:off x="1162202" y="4528109"/>
-            <a:ext cx="7677302" cy="502920"/>
+            <a:off x="1162202" y="4224528"/>
+            <a:ext cx="7677302" cy="658368"/>
           </a:xfrm>
           <a:prstGeom prst="rect">
             <a:avLst/>
@@ -7974,10 +7986,13 @@
           <a:lstStyle/>
           <a:p>
             <a:pPr marL="0" indent="0" algn="l">
+              <a:spcAft>
+                <a:spcPts val="500"/>
+              </a:spcAft>
               <a:buNone/>
             </a:pPr>
             <a:r>
-              <a:rPr lang="en-US" sz="1050" i="1" dirty="0">
+              <a:rPr lang="en-US" sz="1200" i="1" dirty="0">
                 <a:solidFill>
                   <a:srgbClr val="FFFFFF">
                     <a:alpha val="70000"/>
@@ -7993,10 +8008,13 @@
           </a:p>
           <a:p>
             <a:pPr marL="0" indent="0" algn="l">
+              <a:spcAft>
+                <a:spcPts val="500"/>
+              </a:spcAft>
               <a:buNone/>
             </a:pPr>
             <a:r>
-              <a:rPr lang="en-US" sz="1050" i="1" dirty="0">
+              <a:rPr lang="en-US" sz="1200" i="1" dirty="0">
                 <a:solidFill>
                   <a:srgbClr val="FFFFFF">
                     <a:alpha val="70000"/>
@@ -8012,10 +8030,13 @@
           </a:p>
           <a:p>
             <a:pPr marL="0" indent="0" algn="l">
+              <a:spcAft>
+                <a:spcPts val="500"/>
+              </a:spcAft>
               <a:buNone/>
             </a:pPr>
             <a:r>
-              <a:rPr lang="en-US" sz="1050" i="1" dirty="0">
+              <a:rPr lang="en-US" sz="1200" i="1" dirty="0">
                 <a:solidFill>
                   <a:srgbClr val="FFFFFF">
                     <a:alpha val="70000"/>
@@ -8039,8 +8060,8 @@
         </p:nvSpPr>
         <p:spPr>
           <a:xfrm>
-            <a:off x="961949" y="5108753"/>
-            <a:ext cx="10267798" cy="1188720"/>
+            <a:off x="961949" y="5047488"/>
+            <a:ext cx="10267798" cy="1307592"/>
           </a:xfrm>
           <a:prstGeom prst="roundRect">
             <a:avLst>
@@ -8075,7 +8096,7 @@
         </p:nvSpPr>
         <p:spPr>
           <a:xfrm>
-            <a:off x="1162202" y="5309006"/>
+            <a:off x="1162202" y="5166359"/>
             <a:ext cx="1548079" cy="191110"/>
           </a:xfrm>
           <a:prstGeom prst="rect">
@@ -8114,8 +8135,8 @@
         </p:nvSpPr>
         <p:spPr>
           <a:xfrm>
-            <a:off x="1162202" y="5575097"/>
-            <a:ext cx="8458200" cy="658368"/>
+            <a:off x="1162202" y="5431536"/>
+            <a:ext cx="8458200" cy="832103"/>
           </a:xfrm>
           <a:prstGeom prst="rect">
             <a:avLst/>
@@ -8128,10 +8149,13 @@
           <a:lstStyle/>
           <a:p>
             <a:pPr marL="0" indent="0" algn="l">
+              <a:spcAft>
+                <a:spcPts val="500"/>
+              </a:spcAft>
               <a:buNone/>
             </a:pPr>
             <a:r>
-              <a:rPr lang="en-US" sz="1050" i="1" dirty="0">
+              <a:rPr lang="en-US" sz="1200" i="1" dirty="0">
                 <a:solidFill>
                   <a:srgbClr val="FFFFFF">
                     <a:alpha val="70000"/>
@@ -8147,10 +8171,13 @@
           </a:p>
           <a:p>
             <a:pPr marL="0" indent="0" algn="l">
+              <a:spcAft>
+                <a:spcPts val="500"/>
+              </a:spcAft>
               <a:buNone/>
             </a:pPr>
             <a:r>
-              <a:rPr lang="en-US" sz="1050" i="1" dirty="0">
+              <a:rPr lang="en-US" sz="1200" i="1" dirty="0">
                 <a:solidFill>
                   <a:srgbClr val="FFFFFF">
                     <a:alpha val="70000"/>
@@ -8166,10 +8193,13 @@
           </a:p>
           <a:p>
             <a:pPr marL="0" indent="0" algn="l">
+              <a:spcAft>
+                <a:spcPts val="500"/>
+              </a:spcAft>
               <a:buNone/>
             </a:pPr>
             <a:r>
-              <a:rPr lang="en-US" sz="1050" i="1" dirty="0">
+              <a:rPr lang="en-US" sz="1200" i="1" dirty="0">
                 <a:solidFill>
                   <a:srgbClr val="FFFFFF">
                     <a:alpha val="70000"/>
@@ -8185,10 +8215,13 @@
           </a:p>
           <a:p>
             <a:pPr marL="0" indent="0" algn="l">
+              <a:spcAft>
+                <a:spcPts val="500"/>
+              </a:spcAft>
               <a:buNone/>
             </a:pPr>
             <a:r>
-              <a:rPr lang="en-US" sz="1050" i="1" dirty="0">
+              <a:rPr lang="en-US" sz="1200" i="1" dirty="0">
                 <a:solidFill>
                   <a:srgbClr val="FFFFFF">
                     <a:alpha val="70000"/>
@@ -8804,8 +8837,8 @@
         </p:nvSpPr>
         <p:spPr>
           <a:xfrm>
-            <a:off x="961949" y="4134002"/>
-            <a:ext cx="10267798" cy="2212848"/>
+            <a:off x="961949" y="3840480"/>
+            <a:ext cx="10267798" cy="2487168"/>
           </a:xfrm>
           <a:prstGeom prst="roundRect">
             <a:avLst>
@@ -8840,7 +8873,7 @@
         </p:nvSpPr>
         <p:spPr>
           <a:xfrm>
-            <a:off x="1200607" y="4372661"/>
+            <a:off x="1200607" y="3959352"/>
             <a:ext cx="1367028" cy="191110"/>
           </a:xfrm>
           <a:prstGeom prst="rect">
@@ -8879,8 +8912,8 @@
         </p:nvSpPr>
         <p:spPr>
           <a:xfrm>
-            <a:off x="1200607" y="4648810"/>
-            <a:ext cx="8996782" cy="365760"/>
+            <a:off x="1200607" y="4224528"/>
+            <a:ext cx="8996782" cy="2011680"/>
           </a:xfrm>
           <a:prstGeom prst="rect">
             <a:avLst/>
@@ -8893,10 +8926,13 @@
           <a:lstStyle/>
           <a:p>
             <a:pPr marL="0" indent="0" algn="l">
+              <a:spcAft>
+                <a:spcPts val="500"/>
+              </a:spcAft>
               <a:buNone/>
             </a:pPr>
             <a:r>
-              <a:rPr lang="en-US" sz="1000" i="1" dirty="0">
+              <a:rPr lang="en-US" sz="1150" i="1" dirty="0">
                 <a:solidFill>
                   <a:srgbClr val="FFFFFF">
                     <a:alpha val="70000"/>
@@ -8912,10 +8948,13 @@
           </a:p>
           <a:p>
             <a:pPr marL="0" indent="0" algn="l">
+              <a:spcAft>
+                <a:spcPts val="500"/>
+              </a:spcAft>
               <a:buNone/>
             </a:pPr>
             <a:r>
-              <a:rPr lang="en-US" sz="1000" i="1" dirty="0">
+              <a:rPr lang="en-US" sz="1150" i="1" dirty="0">
                 <a:solidFill>
                   <a:srgbClr val="FFFFFF">
                     <a:alpha val="70000"/>
@@ -9057,8 +9096,8 @@
         </p:blipFill>
         <p:spPr>
           <a:xfrm>
-            <a:off x="2258568" y="4983480"/>
-            <a:ext cx="7680960" cy="1627322"/>
+            <a:off x="2304288" y="4709160"/>
+            <a:ext cx="7589520" cy="1607949"/>
           </a:xfrm>
           <a:prstGeom prst="rect">
             <a:avLst/>
@@ -9558,8 +9597,8 @@
         </p:nvSpPr>
         <p:spPr>
           <a:xfrm>
-            <a:off x="961949" y="3845052"/>
-            <a:ext cx="5020056" cy="2331720"/>
+            <a:off x="961949" y="3703320"/>
+            <a:ext cx="5020056" cy="2633472"/>
           </a:xfrm>
           <a:prstGeom prst="roundRect">
             <a:avLst>
@@ -9594,7 +9633,7 @@
         </p:nvSpPr>
         <p:spPr>
           <a:xfrm>
-            <a:off x="1200607" y="4082796"/>
+            <a:off x="1200607" y="3822191"/>
             <a:ext cx="1271930" cy="191110"/>
           </a:xfrm>
           <a:prstGeom prst="rect">
@@ -9633,8 +9672,8 @@
         </p:nvSpPr>
         <p:spPr>
           <a:xfrm>
-            <a:off x="1200607" y="4349801"/>
-            <a:ext cx="4429354" cy="1737360"/>
+            <a:off x="1200607" y="4087368"/>
+            <a:ext cx="4429354" cy="2157984"/>
           </a:xfrm>
           <a:prstGeom prst="rect">
             <a:avLst/>
@@ -9647,10 +9686,13 @@
           <a:lstStyle/>
           <a:p>
             <a:pPr marL="0" indent="0" algn="l">
+              <a:spcAft>
+                <a:spcPts val="500"/>
+              </a:spcAft>
               <a:buNone/>
             </a:pPr>
             <a:r>
-              <a:rPr lang="en-US" sz="1050" i="1" dirty="0">
+              <a:rPr lang="en-US" sz="1150" i="1" dirty="0">
                 <a:solidFill>
                   <a:srgbClr val="FFFFFF">
                     <a:alpha val="70000"/>
@@ -9666,10 +9708,13 @@
           </a:p>
           <a:p>
             <a:pPr marL="0" indent="0" algn="l">
+              <a:spcAft>
+                <a:spcPts val="500"/>
+              </a:spcAft>
               <a:buNone/>
             </a:pPr>
             <a:r>
-              <a:rPr lang="en-US" sz="1050" i="1" dirty="0">
+              <a:rPr lang="en-US" sz="1150" i="1" dirty="0">
                 <a:solidFill>
                   <a:srgbClr val="FFFFFF">
                     <a:alpha val="70000"/>
@@ -9685,10 +9730,13 @@
           </a:p>
           <a:p>
             <a:pPr marL="0" indent="0" algn="l">
+              <a:spcAft>
+                <a:spcPts val="500"/>
+              </a:spcAft>
               <a:buNone/>
             </a:pPr>
             <a:r>
-              <a:rPr lang="en-US" sz="1050" i="1" dirty="0">
+              <a:rPr lang="en-US" sz="1150" i="1" dirty="0">
                 <a:solidFill>
                   <a:srgbClr val="FFFFFF">
                     <a:alpha val="70000"/>
@@ -9712,8 +9760,8 @@
         </p:nvSpPr>
         <p:spPr>
           <a:xfrm>
-            <a:off x="6210605" y="3845052"/>
-            <a:ext cx="5020056" cy="2331720"/>
+            <a:off x="6210605" y="3703320"/>
+            <a:ext cx="5020056" cy="2633472"/>
           </a:xfrm>
           <a:prstGeom prst="roundRect">
             <a:avLst>
@@ -9748,7 +9796,7 @@
         </p:nvSpPr>
         <p:spPr>
           <a:xfrm>
-            <a:off x="6448349" y="4082796"/>
+            <a:off x="6448349" y="3822191"/>
             <a:ext cx="1901038" cy="191110"/>
           </a:xfrm>
           <a:prstGeom prst="rect">
@@ -9787,8 +9835,8 @@
         </p:nvSpPr>
         <p:spPr>
           <a:xfrm>
-            <a:off x="6448349" y="4349801"/>
-            <a:ext cx="4239158" cy="1737360"/>
+            <a:off x="6448349" y="4087368"/>
+            <a:ext cx="4239158" cy="2157984"/>
           </a:xfrm>
           <a:prstGeom prst="rect">
             <a:avLst/>
@@ -9801,10 +9849,13 @@
           <a:lstStyle/>
           <a:p>
             <a:pPr marL="0" indent="0" algn="l">
+              <a:spcAft>
+                <a:spcPts val="500"/>
+              </a:spcAft>
               <a:buNone/>
             </a:pPr>
             <a:r>
-              <a:rPr lang="en-US" sz="1050" i="1" dirty="0">
+              <a:rPr lang="en-US" sz="1150" i="1" dirty="0">
                 <a:solidFill>
                   <a:srgbClr val="FFFFFF">
                     <a:alpha val="70000"/>
@@ -9820,10 +9871,13 @@
           </a:p>
           <a:p>
             <a:pPr marL="0" indent="0" algn="l">
+              <a:spcAft>
+                <a:spcPts val="500"/>
+              </a:spcAft>
               <a:buNone/>
             </a:pPr>
             <a:r>
-              <a:rPr lang="en-US" sz="1050" i="1" dirty="0">
+              <a:rPr lang="en-US" sz="1150" i="1" dirty="0">
                 <a:solidFill>
                   <a:srgbClr val="FFFFFF">
                     <a:alpha val="70000"/>
@@ -9839,10 +9893,13 @@
           </a:p>
           <a:p>
             <a:pPr marL="0" indent="0" algn="l">
+              <a:spcAft>
+                <a:spcPts val="500"/>
+              </a:spcAft>
               <a:buNone/>
             </a:pPr>
             <a:r>
-              <a:rPr lang="en-US" sz="1050" i="1" dirty="0">
+              <a:rPr lang="en-US" sz="1150" i="1" dirty="0">
                 <a:solidFill>
                   <a:srgbClr val="FFFFFF">
                     <a:alpha val="70000"/>
@@ -9858,10 +9915,13 @@
           </a:p>
           <a:p>
             <a:pPr marL="0" indent="0" algn="l">
+              <a:spcAft>
+                <a:spcPts val="500"/>
+              </a:spcAft>
               <a:buNone/>
             </a:pPr>
             <a:r>
-              <a:rPr lang="en-US" sz="1050" i="1" dirty="0">
+              <a:rPr lang="en-US" sz="1150" i="1" dirty="0">
                 <a:solidFill>
                   <a:srgbClr val="FFFFFF">
                     <a:alpha val="70000"/>
@@ -10480,8 +10540,8 @@
         </p:nvSpPr>
         <p:spPr>
           <a:xfrm>
-            <a:off x="961949" y="4210812"/>
-            <a:ext cx="5020056" cy="955547"/>
+            <a:off x="961949" y="3840480"/>
+            <a:ext cx="5020056" cy="1298448"/>
           </a:xfrm>
           <a:prstGeom prst="roundRect">
             <a:avLst>
@@ -10523,7 +10583,7 @@
         </p:blipFill>
         <p:spPr>
           <a:xfrm>
-            <a:off x="1200607" y="4233672"/>
+            <a:off x="1200607" y="3941063"/>
             <a:ext cx="152705" cy="152705"/>
           </a:xfrm>
           <a:prstGeom prst="rect">
@@ -10539,7 +10599,7 @@
         </p:nvSpPr>
         <p:spPr>
           <a:xfrm>
-            <a:off x="1466698" y="4224528"/>
+            <a:off x="1466698" y="3931920"/>
             <a:ext cx="1324051" cy="219456"/>
           </a:xfrm>
           <a:prstGeom prst="rect">
@@ -10578,8 +10638,8 @@
         </p:nvSpPr>
         <p:spPr>
           <a:xfrm>
-            <a:off x="1200607" y="4462272"/>
-            <a:ext cx="4148633" cy="566928"/>
+            <a:off x="1200607" y="4187952"/>
+            <a:ext cx="4148633" cy="777240"/>
           </a:xfrm>
           <a:prstGeom prst="rect">
             <a:avLst/>
@@ -10595,7 +10655,7 @@
               <a:buNone/>
             </a:pPr>
             <a:r>
-              <a:rPr lang="en-US" sz="1000" dirty="0">
+              <a:rPr lang="en-US" sz="1150" dirty="0">
                 <a:solidFill>
                   <a:srgbClr val="D1D5DB"/>
                 </a:solidFill>
@@ -10612,7 +10672,7 @@
               <a:buNone/>
             </a:pPr>
             <a:r>
-              <a:rPr lang="en-US" sz="1000" dirty="0">
+              <a:rPr lang="en-US" sz="1150" dirty="0">
                 <a:solidFill>
                   <a:srgbClr val="D1D5DB"/>
                 </a:solidFill>
@@ -10634,8 +10694,8 @@
         </p:nvSpPr>
         <p:spPr>
           <a:xfrm>
-            <a:off x="6210605" y="4210812"/>
-            <a:ext cx="5020056" cy="955547"/>
+            <a:off x="6210605" y="3840480"/>
+            <a:ext cx="5020056" cy="1298448"/>
           </a:xfrm>
           <a:prstGeom prst="roundRect">
             <a:avLst>
@@ -10677,7 +10737,7 @@
         </p:blipFill>
         <p:spPr>
           <a:xfrm>
-            <a:off x="6448349" y="4233672"/>
+            <a:off x="6448349" y="3941063"/>
             <a:ext cx="171907" cy="152705"/>
           </a:xfrm>
           <a:prstGeom prst="rect">
@@ -10693,7 +10753,7 @@
         </p:nvSpPr>
         <p:spPr>
           <a:xfrm>
-            <a:off x="6734556" y="4224528"/>
+            <a:off x="6734556" y="3931920"/>
             <a:ext cx="1924812" cy="219456"/>
           </a:xfrm>
           <a:prstGeom prst="rect">
@@ -10732,8 +10792,8 @@
         </p:nvSpPr>
         <p:spPr>
           <a:xfrm>
-            <a:off x="6448349" y="4462272"/>
-            <a:ext cx="3986784" cy="731520"/>
+            <a:off x="6448349" y="4187952"/>
+            <a:ext cx="3986784" cy="868680"/>
           </a:xfrm>
           <a:prstGeom prst="rect">
             <a:avLst/>
@@ -10749,7 +10809,7 @@
               <a:buNone/>
             </a:pPr>
             <a:r>
-              <a:rPr lang="en-US" sz="1000" dirty="0">
+              <a:rPr lang="en-US" sz="1150" dirty="0">
                 <a:solidFill>
                   <a:srgbClr val="D1D5DB"/>
                 </a:solidFill>
@@ -10766,7 +10826,7 @@
               <a:buNone/>
             </a:pPr>
             <a:r>
-              <a:rPr lang="en-US" sz="1000" dirty="0">
+              <a:rPr lang="en-US" sz="1150" dirty="0">
                 <a:solidFill>
                   <a:srgbClr val="D1D5DB"/>
                 </a:solidFill>
@@ -10783,7 +10843,7 @@
               <a:buNone/>
             </a:pPr>
             <a:r>
-              <a:rPr lang="en-US" sz="1000" dirty="0">
+              <a:rPr lang="en-US" sz="1150" dirty="0">
                 <a:solidFill>
                   <a:srgbClr val="D1D5DB"/>
                 </a:solidFill>
@@ -10800,7 +10860,7 @@
               <a:buNone/>
             </a:pPr>
             <a:r>
-              <a:rPr lang="en-US" sz="1000" dirty="0">
+              <a:rPr lang="en-US" sz="1150" dirty="0">
                 <a:solidFill>
                   <a:srgbClr val="D1D5DB"/>
                 </a:solidFill>
@@ -10940,8 +11000,8 @@
         </p:blipFill>
         <p:spPr>
           <a:xfrm>
-            <a:off x="2331720" y="5257800"/>
-            <a:ext cx="7498079" cy="1131066"/>
+            <a:off x="2304288" y="5230368"/>
+            <a:ext cx="7589520" cy="1144859"/>
           </a:xfrm>
           <a:prstGeom prst="rect">
             <a:avLst/>

</xml_diff>

<commit_message>
Align the deck with the recorded presentation script
Three places showed something different from what the narration says.

Slide 3's three ideas are now numbered and ordered as spoken - provided
data, single-pass restoration, then residual learning as the headline
third point. Slide 4 carries the parameter count and checkpoint size,
which the script states while that slide is on screen but which only
appeared on the previous slide. Slide 5 gains an explicit KNOWN
LIMITATION line, because the script narrates the difficult cases there
while the slide previously showed only innovation.
</commit_message>
<xml_diff>
--- a/BYTE BRIGADE_PS01.pptx
+++ b/BYTE BRIGADE_PS01.pptx
@@ -8002,7 +8002,7 @@
                 <a:ea typeface="Poppins" pitchFamily="34" charset="-122"/>
                 <a:cs typeface="Poppins" pitchFamily="34" charset="-120"/>
               </a:rPr>
-              <a:t>One small network denoises and 2x super-resolves in a single pass.</a:t>
+              <a:t>1. Supervised on the 3,200 provided pairs - no external datasets, no pretrained restoration weights.</a:t>
             </a:r>
             <a:endParaRPr lang="en-US" sz="1200" dirty="0"/>
           </a:p>
@@ -8024,7 +8024,7 @@
                 <a:ea typeface="Poppins" pitchFamily="34" charset="-122"/>
                 <a:cs typeface="Poppins" pitchFamily="34" charset="-120"/>
               </a:rPr>
-              <a:t>Supervised on the 3,200 provided pairs - no external data, no pretrained restoration weights.</a:t>
+              <a:t>2. One network performs denoising and 2x super-resolution in a single pass.</a:t>
             </a:r>
             <a:endParaRPr lang="en-US" sz="1200" dirty="0"/>
           </a:p>
@@ -8046,7 +8046,7 @@
                 <a:ea typeface="Poppins" pitchFamily="34" charset="-122"/>
                 <a:cs typeface="Poppins" pitchFamily="34" charset="-120"/>
               </a:rPr>
-              <a:t>Predicts only a correction on a bicubic upscale, which strongly constrains hallucination.</a:t>
+              <a:t>3. Residual learning - the model corrects rather than generates, which strongly constrains hallucination.</a:t>
             </a:r>
             <a:endParaRPr lang="en-US" sz="1200" dirty="0"/>
           </a:p>
@@ -8823,7 +8823,7 @@
                 <a:ea typeface="Poppins" pitchFamily="34" charset="-122"/>
                 <a:cs typeface="Poppins" pitchFamily="34" charset="-120"/>
               </a:rPr>
-              <a:t>NAFNet-SR: 24 simplified restoration blocks and a learned 2x upsampler, added to a bicubic upscale so the network predicts only a correction.</a:t>
+              <a:t>NAFNet-SR: 24 NAFNet blocks with 48 channels and a learned 2x PixelShuffle upsampler - 0.53 M parameters, 2.3 MB inference checkpoint.</a:t>
             </a:r>
             <a:endParaRPr lang="en-US" sz="1800" dirty="0"/>
           </a:p>
@@ -9850,12 +9850,12 @@
           <a:p>
             <a:pPr marL="0" indent="0" algn="l">
               <a:spcAft>
-                <a:spcPts val="500"/>
+                <a:spcPts val="400"/>
               </a:spcAft>
               <a:buNone/>
             </a:pPr>
             <a:r>
-              <a:rPr lang="en-US" sz="1150" i="1" dirty="0">
+              <a:rPr lang="en-US" sz="1100" i="1" dirty="0">
                 <a:solidFill>
                   <a:srgbClr val="FFFFFF">
                     <a:alpha val="70000"/>
@@ -9865,19 +9865,19 @@
                 <a:ea typeface="Poppins" pitchFamily="34" charset="-122"/>
                 <a:cs typeface="Poppins" pitchFamily="34" charset="-120"/>
               </a:rPr>
-              <a:t>SMALLER: 0.53 M parameters (2.3 MB) versus 10-26 M for Restormer or SwinIR, so throughput - an explicit scoring axis - is a strength.</a:t>
+              <a:t>SMALLER: 0.53 M parameters (2.3 MB) vs 10-26 M for Restormer or SwinIR - throughput is a strength, not a compromise.</a:t>
             </a:r>
             <a:endParaRPr lang="en-US" sz="1200" dirty="0"/>
           </a:p>
           <a:p>
             <a:pPr marL="0" indent="0" algn="l">
               <a:spcAft>
-                <a:spcPts val="500"/>
+                <a:spcPts val="400"/>
               </a:spcAft>
               <a:buNone/>
             </a:pPr>
             <a:r>
-              <a:rPr lang="en-US" sz="1150" i="1" dirty="0">
+              <a:rPr lang="en-US" sz="1100" i="1" dirty="0">
                 <a:solidFill>
                   <a:srgbClr val="FFFFFF">
                     <a:alpha val="70000"/>
@@ -9894,12 +9894,12 @@
           <a:p>
             <a:pPr marL="0" indent="0" algn="l">
               <a:spcAft>
-                <a:spcPts val="500"/>
+                <a:spcPts val="400"/>
               </a:spcAft>
               <a:buNone/>
             </a:pPr>
             <a:r>
-              <a:rPr lang="en-US" sz="1150" i="1" dirty="0">
+              <a:rPr lang="en-US" sz="1100" i="1" dirty="0">
                 <a:solidFill>
                   <a:srgbClr val="FFFFFF">
                     <a:alpha val="70000"/>
@@ -9916,12 +9916,12 @@
           <a:p>
             <a:pPr marL="0" indent="0" algn="l">
               <a:spcAft>
-                <a:spcPts val="500"/>
+                <a:spcPts val="400"/>
               </a:spcAft>
               <a:buNone/>
             </a:pPr>
             <a:r>
-              <a:rPr lang="en-US" sz="1150" i="1" dirty="0">
+              <a:rPr lang="en-US" sz="1100" i="1" dirty="0">
                 <a:solidFill>
                   <a:srgbClr val="FFFFFF">
                     <a:alpha val="70000"/>
@@ -9932,6 +9932,28 @@
                 <a:cs typeface="Poppins" pitchFamily="34" charset="-120"/>
               </a:rPr>
               <a:t>REPRODUCIBLE: seeded splits, one-command training and inference, weights and runtime report committed to the repository.</a:t>
+            </a:r>
+            <a:endParaRPr lang="en-US" sz="1200" dirty="0"/>
+          </a:p>
+          <a:p>
+            <a:pPr marL="0" indent="0" algn="l">
+              <a:spcAft>
+                <a:spcPts val="400"/>
+              </a:spcAft>
+              <a:buNone/>
+            </a:pPr>
+            <a:r>
+              <a:rPr lang="en-US" sz="1100" i="1" dirty="0">
+                <a:solidFill>
+                  <a:srgbClr val="FFFFFF">
+                    <a:alpha val="70000"/>
+                  </a:srgbClr>
+                </a:solidFill>
+                <a:latin typeface="Poppins" pitchFamily="34" charset="0"/>
+                <a:ea typeface="Poppins" pitchFamily="34" charset="-122"/>
+                <a:cs typeface="Poppins" pitchFamily="34" charset="-120"/>
+              </a:rPr>
+              <a:t>KNOWN LIMITATION: very fine texture gains least - downsampling destroys detail we will not invent.</a:t>
             </a:r>
             <a:endParaRPr lang="en-US" sz="1200" dirty="0"/>
           </a:p>

</xml_diff>

<commit_message>
Point slide 8 at the final demo video
The video link text box had been lost from the deck, leaving the label and
its card with nothing inside. Restored by cloning the GitHub link box so
the styling matches, and set to the final recording.
</commit_message>
<xml_diff>
--- a/BYTE BRIGADE_PS01.pptx
+++ b/BYTE BRIGADE_PS01.pptx
@@ -11089,6 +11089,45 @@
           </a:prstGeom>
         </p:spPr>
       </p:pic>
+      <p:sp>
+        <p:nvSpPr>
+          <p:cNvPr id="20" name="Text 13"/>
+          <p:cNvSpPr txBox="1"/>
+          <p:nvPr/>
+        </p:nvSpPr>
+        <p:spPr>
+          <a:xfrm>
+            <a:off x="2866644" y="5243170"/>
+            <a:ext cx="5120640" cy="238658"/>
+          </a:xfrm>
+          <a:prstGeom prst="rect">
+            <a:avLst/>
+          </a:prstGeom>
+          <a:noFill/>
+          <a:ln/>
+        </p:spPr>
+        <p:txBody>
+          <a:bodyPr wrap="square" lIns="0" tIns="0" rIns="0" bIns="0" rtlCol="0" anchor="ctr"/>
+          <a:lstStyle/>
+          <a:p>
+            <a:pPr marL="0" indent="0" algn="l">
+              <a:buNone/>
+            </a:pPr>
+            <a:r>
+              <a:rPr lang="en-US" sz="1300" i="1" dirty="0">
+                <a:solidFill>
+                  <a:srgbClr val="D1D5DB"/>
+                </a:solidFill>
+                <a:latin typeface="Poppins" pitchFamily="34" charset="0"/>
+                <a:ea typeface="Poppins" pitchFamily="34" charset="-122"/>
+                <a:cs typeface="Poppins" pitchFamily="34" charset="-120"/>
+              </a:rPr>
+              <a:t>https://youtu.be/0eGuJqKfNBQ</a:t>
+            </a:r>
+            <a:endParaRPr lang="en-US" sz="1300" dirty="0"/>
+          </a:p>
+        </p:txBody>
+      </p:sp>
     </p:spTree>
   </p:cSld>
   <p:clrMapOvr>

</xml_diff>